<commit_message>
S01+S02 v4: Cuenta tu caso (hasta 4 abogados) + apostilla/defensa/tramites
</commit_message>
<xml_diff>
--- a/Viernes-19/S02_Viernes-19_1_Carrusel_Todo-lo-que-resuelves_1x1.pptx
+++ b/Viernes-19/S02_Viernes-19_1_Carrusel_Todo-lo-que-resuelves_1x1.pptx
@@ -3306,7 +3306,7 @@
                 </a:solidFill>
                 <a:latin typeface="Inter"/>
               </a:rPr>
-              <a:t>6 cosas que resuelves sin salir de casa.</a:t>
+              <a:t>Todo lo que resuelves sin salir de casa.</a:t>
             </a:r>
           </a:p>
         </p:txBody>
@@ -3489,7 +3489,7 @@
         <p:spPr>
           <a:xfrm>
             <a:off x="777240" y="2606040"/>
-            <a:ext cx="6675120" cy="1562608"/>
+            <a:ext cx="6675120" cy="2197608"/>
           </a:xfrm>
           <a:prstGeom prst="rect">
             <a:avLst/>
@@ -3514,7 +3514,7 @@
                 </a:solidFill>
                 <a:latin typeface="Inter"/>
               </a:rPr>
-              <a:t>Trámites.</a:t>
+              <a:t>Trámites y apostillas.</a:t>
             </a:r>
           </a:p>
         </p:txBody>
@@ -3697,7 +3697,7 @@
         <p:spPr>
           <a:xfrm>
             <a:off x="777240" y="2606040"/>
-            <a:ext cx="6675120" cy="1562608"/>
+            <a:ext cx="6675120" cy="2197608"/>
           </a:xfrm>
           <a:prstGeom prst="rect">
             <a:avLst/>
@@ -3722,7 +3722,7 @@
                 </a:solidFill>
                 <a:latin typeface="Inter"/>
               </a:rPr>
-              <a:t>Contabilidad.</a:t>
+              <a:t>Defensa y casos legales.</a:t>
             </a:r>
           </a:p>
         </p:txBody>
@@ -3801,7 +3801,7 @@
         <p:spPr>
           <a:xfrm>
             <a:off x="777240" y="2606040"/>
-            <a:ext cx="6675120" cy="1562608"/>
+            <a:ext cx="6675120" cy="2197608"/>
           </a:xfrm>
           <a:prstGeom prst="rect">
             <a:avLst/>
@@ -3826,7 +3826,7 @@
                 </a:solidFill>
                 <a:latin typeface="Inter"/>
               </a:rPr>
-              <a:t>Tu plan a medida.</a:t>
+              <a:t>Contabilidad y tu plan.</a:t>
             </a:r>
           </a:p>
         </p:txBody>
@@ -3905,7 +3905,7 @@
         <p:spPr>
           <a:xfrm>
             <a:off x="777240" y="2606040"/>
-            <a:ext cx="6675120" cy="2197608"/>
+            <a:ext cx="6675120" cy="2832607"/>
           </a:xfrm>
           <a:prstGeom prst="rect">
             <a:avLst/>
@@ -3930,7 +3930,7 @@
                 </a:solidFill>
                 <a:latin typeface="Inter"/>
               </a:rPr>
-              <a:t>Cuenta tu caso, gratis.</a:t>
+              <a:t>Cuenta tu caso: hasta 4 abogados te contactan.</a:t>
             </a:r>
           </a:p>
         </p:txBody>

</xml_diff>